<commit_message>
copilot refinement through claude
</commit_message>
<xml_diff>
--- a/E-HAZID Copilot Presentation.pptx
+++ b/E-HAZID Copilot Presentation.pptx
@@ -5,13 +5,13 @@
     <p:sldMasterId id="2147483648" r:id="rId1"/>
   </p:sldMasterIdLst>
   <p:sldIdLst>
-    <p:sldId id="256" r:id="rId7"/>
-    <p:sldId id="257" r:id="rId8"/>
-    <p:sldId id="258" r:id="rId9"/>
-    <p:sldId id="259" r:id="rId10"/>
-    <p:sldId id="260" r:id="rId11"/>
+    <p:sldId id="256" r:id="rId2"/>
+    <p:sldId id="257" r:id="rId3"/>
+    <p:sldId id="258" r:id="rId4"/>
+    <p:sldId id="259" r:id="rId5"/>
+    <p:sldId id="260" r:id="rId6"/>
   </p:sldIdLst>
-  <p:sldSz cx="12192000" cy="6858000" type="screen4x3"/>
+  <p:sldSz cx="12192000" cy="6858000"/>
   <p:notesSz cx="6858000" cy="9144000"/>
   <p:defaultTextStyle>
     <a:defPPr>
@@ -108,7 +108,52 @@
       </a:defRPr>
     </a:lvl9pPr>
   </p:defaultTextStyle>
+  <p:extLst>
+    <p:ext uri="{EFAFB233-063F-42B5-8137-9DF3F51BA10A}">
+      <p15:sldGuideLst xmlns:p15="http://schemas.microsoft.com/office/powerpoint/2012/main">
+        <p15:guide id="1" orient="horz" pos="2160">
+          <p15:clr>
+            <a:srgbClr val="A4A3A4"/>
+          </p15:clr>
+        </p15:guide>
+        <p15:guide id="2" pos="2880">
+          <p15:clr>
+            <a:srgbClr val="A4A3A4"/>
+          </p15:clr>
+        </p15:guide>
+      </p15:sldGuideLst>
+    </p:ext>
+  </p:extLst>
 </p:presentation>
+</file>
+
+<file path=ppt/changesInfos/changesInfo1.xml><?xml version="1.0" encoding="utf-8"?>
+<pc:chgInfo xmlns:a="http://schemas.openxmlformats.org/drawingml/2006/main" xmlns:r="http://schemas.openxmlformats.org/officeDocument/2006/relationships" xmlns:ac="http://schemas.microsoft.com/office/drawing/2013/main/command" xmlns:pc="http://schemas.microsoft.com/office/powerpoint/2013/main/command">
+  <pc:docChgLst>
+    <pc:chgData name="Sasmal, Sankar PTIN-DRX/D/L/D" userId="a3df832e-963b-476a-b36c-b830cef0bb7b" providerId="ADAL" clId="{29B79650-4591-4D0E-84F9-FE6CA68FEE0F}"/>
+    <pc:docChg chg="custSel modSld">
+      <pc:chgData name="Sasmal, Sankar PTIN-DRX/D/L/D" userId="a3df832e-963b-476a-b36c-b830cef0bb7b" providerId="ADAL" clId="{29B79650-4591-4D0E-84F9-FE6CA68FEE0F}" dt="2026-09-17T05:43:48.670" v="1" actId="478"/>
+      <pc:docMkLst>
+        <pc:docMk/>
+      </pc:docMkLst>
+      <pc:sldChg chg="delSp modSp mod">
+        <pc:chgData name="Sasmal, Sankar PTIN-DRX/D/L/D" userId="a3df832e-963b-476a-b36c-b830cef0bb7b" providerId="ADAL" clId="{29B79650-4591-4D0E-84F9-FE6CA68FEE0F}" dt="2026-09-17T05:43:48.670" v="1" actId="478"/>
+        <pc:sldMkLst>
+          <pc:docMk/>
+          <pc:sldMk cId="0" sldId="260"/>
+        </pc:sldMkLst>
+        <pc:picChg chg="del mod">
+          <ac:chgData name="Sasmal, Sankar PTIN-DRX/D/L/D" userId="a3df832e-963b-476a-b36c-b830cef0bb7b" providerId="ADAL" clId="{29B79650-4591-4D0E-84F9-FE6CA68FEE0F}" dt="2026-09-17T05:43:48.670" v="1" actId="478"/>
+          <ac:picMkLst>
+            <pc:docMk/>
+            <pc:sldMk cId="0" sldId="260"/>
+            <ac:picMk id="2" creationId="{00000000-0000-0000-0000-000000000000}"/>
+          </ac:picMkLst>
+        </pc:picChg>
+      </pc:sldChg>
+    </pc:docChg>
+  </pc:docChgLst>
+</pc:chgInfo>
 </file>
 
 <file path=ppt/slideLayouts/slideLayout1.xml><?xml version="1.0" encoding="utf-8"?>
@@ -149,10 +194,9 @@
           <a:lstStyle/>
           <a:p>
             <a:r>
-              <a:rPr lang="en-US" smtClean="0"/>
+              <a:rPr lang="en-US"/>
               <a:t>Click to edit Master title style</a:t>
             </a:r>
-            <a:endParaRPr lang="en-US"/>
           </a:p>
         </p:txBody>
       </p:sp>
@@ -268,10 +312,9 @@
           </a:lstStyle>
           <a:p>
             <a:r>
-              <a:rPr lang="en-US" smtClean="0"/>
+              <a:rPr lang="en-US"/>
               <a:t>Click to edit Master subtitle style</a:t>
             </a:r>
-            <a:endParaRPr lang="en-US"/>
           </a:p>
         </p:txBody>
       </p:sp>
@@ -292,7 +335,7 @@
           <a:p>
             <a:fld id="{5BCAD085-E8A6-8845-BD4E-CB4CCA059FC4}" type="datetimeFigureOut">
               <a:rPr lang="en-US" smtClean="0"/>
-              <a:t>1/27/13</a:t>
+              <a:t>9/17/2026</a:t>
             </a:fld>
             <a:endParaRPr lang="en-US"/>
           </a:p>
@@ -386,10 +429,9 @@
           <a:lstStyle/>
           <a:p>
             <a:r>
-              <a:rPr lang="en-US" smtClean="0"/>
+              <a:rPr lang="en-US"/>
               <a:t>Click to edit Master title style</a:t>
             </a:r>
-            <a:endParaRPr lang="en-US"/>
           </a:p>
         </p:txBody>
       </p:sp>
@@ -410,38 +452,37 @@
           <a:p>
             <a:pPr lvl="0"/>
             <a:r>
-              <a:rPr lang="en-US" smtClean="0"/>
+              <a:rPr lang="en-US"/>
               <a:t>Click to edit Master text styles</a:t>
             </a:r>
           </a:p>
           <a:p>
             <a:pPr lvl="1"/>
             <a:r>
-              <a:rPr lang="en-US" smtClean="0"/>
+              <a:rPr lang="en-US"/>
               <a:t>Second level</a:t>
             </a:r>
           </a:p>
           <a:p>
             <a:pPr lvl="2"/>
             <a:r>
-              <a:rPr lang="en-US" smtClean="0"/>
+              <a:rPr lang="en-US"/>
               <a:t>Third level</a:t>
             </a:r>
           </a:p>
           <a:p>
             <a:pPr lvl="3"/>
             <a:r>
-              <a:rPr lang="en-US" smtClean="0"/>
+              <a:rPr lang="en-US"/>
               <a:t>Fourth level</a:t>
             </a:r>
           </a:p>
           <a:p>
             <a:pPr lvl="4"/>
             <a:r>
-              <a:rPr lang="en-US" smtClean="0"/>
+              <a:rPr lang="en-US"/>
               <a:t>Fifth level</a:t>
             </a:r>
-            <a:endParaRPr lang="en-US"/>
           </a:p>
         </p:txBody>
       </p:sp>
@@ -462,7 +503,7 @@
           <a:p>
             <a:fld id="{5BCAD085-E8A6-8845-BD4E-CB4CCA059FC4}" type="datetimeFigureOut">
               <a:rPr lang="en-US" smtClean="0"/>
-              <a:t>1/27/13</a:t>
+              <a:t>9/17/2026</a:t>
             </a:fld>
             <a:endParaRPr lang="en-US"/>
           </a:p>
@@ -561,10 +602,9 @@
           <a:lstStyle/>
           <a:p>
             <a:r>
-              <a:rPr lang="en-US" smtClean="0"/>
+              <a:rPr lang="en-US"/>
               <a:t>Click to edit Master title style</a:t>
             </a:r>
-            <a:endParaRPr lang="en-US"/>
           </a:p>
         </p:txBody>
       </p:sp>
@@ -590,38 +630,37 @@
           <a:p>
             <a:pPr lvl="0"/>
             <a:r>
-              <a:rPr lang="en-US" smtClean="0"/>
+              <a:rPr lang="en-US"/>
               <a:t>Click to edit Master text styles</a:t>
             </a:r>
           </a:p>
           <a:p>
             <a:pPr lvl="1"/>
             <a:r>
-              <a:rPr lang="en-US" smtClean="0"/>
+              <a:rPr lang="en-US"/>
               <a:t>Second level</a:t>
             </a:r>
           </a:p>
           <a:p>
             <a:pPr lvl="2"/>
             <a:r>
-              <a:rPr lang="en-US" smtClean="0"/>
+              <a:rPr lang="en-US"/>
               <a:t>Third level</a:t>
             </a:r>
           </a:p>
           <a:p>
             <a:pPr lvl="3"/>
             <a:r>
-              <a:rPr lang="en-US" smtClean="0"/>
+              <a:rPr lang="en-US"/>
               <a:t>Fourth level</a:t>
             </a:r>
           </a:p>
           <a:p>
             <a:pPr lvl="4"/>
             <a:r>
-              <a:rPr lang="en-US" smtClean="0"/>
+              <a:rPr lang="en-US"/>
               <a:t>Fifth level</a:t>
             </a:r>
-            <a:endParaRPr lang="en-US"/>
           </a:p>
         </p:txBody>
       </p:sp>
@@ -642,7 +681,7 @@
           <a:p>
             <a:fld id="{5BCAD085-E8A6-8845-BD4E-CB4CCA059FC4}" type="datetimeFigureOut">
               <a:rPr lang="en-US" smtClean="0"/>
-              <a:t>1/27/13</a:t>
+              <a:t>9/17/2026</a:t>
             </a:fld>
             <a:endParaRPr lang="en-US"/>
           </a:p>
@@ -736,10 +775,9 @@
           <a:lstStyle/>
           <a:p>
             <a:r>
-              <a:rPr lang="en-US" smtClean="0"/>
+              <a:rPr lang="en-US"/>
               <a:t>Click to edit Master title style</a:t>
             </a:r>
-            <a:endParaRPr lang="en-US"/>
           </a:p>
         </p:txBody>
       </p:sp>
@@ -760,38 +798,37 @@
           <a:p>
             <a:pPr lvl="0"/>
             <a:r>
-              <a:rPr lang="en-US" smtClean="0"/>
+              <a:rPr lang="en-US"/>
               <a:t>Click to edit Master text styles</a:t>
             </a:r>
           </a:p>
           <a:p>
             <a:pPr lvl="1"/>
             <a:r>
-              <a:rPr lang="en-US" smtClean="0"/>
+              <a:rPr lang="en-US"/>
               <a:t>Second level</a:t>
             </a:r>
           </a:p>
           <a:p>
             <a:pPr lvl="2"/>
             <a:r>
-              <a:rPr lang="en-US" smtClean="0"/>
+              <a:rPr lang="en-US"/>
               <a:t>Third level</a:t>
             </a:r>
           </a:p>
           <a:p>
             <a:pPr lvl="3"/>
             <a:r>
-              <a:rPr lang="en-US" smtClean="0"/>
+              <a:rPr lang="en-US"/>
               <a:t>Fourth level</a:t>
             </a:r>
           </a:p>
           <a:p>
             <a:pPr lvl="4"/>
             <a:r>
-              <a:rPr lang="en-US" smtClean="0"/>
+              <a:rPr lang="en-US"/>
               <a:t>Fifth level</a:t>
             </a:r>
-            <a:endParaRPr lang="en-US"/>
           </a:p>
         </p:txBody>
       </p:sp>
@@ -812,7 +849,7 @@
           <a:p>
             <a:fld id="{5BCAD085-E8A6-8845-BD4E-CB4CCA059FC4}" type="datetimeFigureOut">
               <a:rPr lang="en-US" smtClean="0"/>
-              <a:t>1/27/13</a:t>
+              <a:t>9/17/2026</a:t>
             </a:fld>
             <a:endParaRPr lang="en-US"/>
           </a:p>
@@ -915,10 +952,9 @@
           </a:lstStyle>
           <a:p>
             <a:r>
-              <a:rPr lang="en-US" smtClean="0"/>
+              <a:rPr lang="en-US"/>
               <a:t>Click to edit Master title style</a:t>
             </a:r>
-            <a:endParaRPr lang="en-US"/>
           </a:p>
         </p:txBody>
       </p:sp>
@@ -1035,7 +1071,7 @@
           <a:p>
             <a:pPr lvl="0"/>
             <a:r>
-              <a:rPr lang="en-US" smtClean="0"/>
+              <a:rPr lang="en-US"/>
               <a:t>Click to edit Master text styles</a:t>
             </a:r>
           </a:p>
@@ -1058,7 +1094,7 @@
           <a:p>
             <a:fld id="{5BCAD085-E8A6-8845-BD4E-CB4CCA059FC4}" type="datetimeFigureOut">
               <a:rPr lang="en-US" smtClean="0"/>
-              <a:t>1/27/13</a:t>
+              <a:t>9/17/2026</a:t>
             </a:fld>
             <a:endParaRPr lang="en-US"/>
           </a:p>
@@ -1152,10 +1188,9 @@
           <a:lstStyle/>
           <a:p>
             <a:r>
-              <a:rPr lang="en-US" smtClean="0"/>
+              <a:rPr lang="en-US"/>
               <a:t>Click to edit Master title style</a:t>
             </a:r>
-            <a:endParaRPr lang="en-US"/>
           </a:p>
         </p:txBody>
       </p:sp>
@@ -1209,38 +1244,37 @@
           <a:p>
             <a:pPr lvl="0"/>
             <a:r>
-              <a:rPr lang="en-US" smtClean="0"/>
+              <a:rPr lang="en-US"/>
               <a:t>Click to edit Master text styles</a:t>
             </a:r>
           </a:p>
           <a:p>
             <a:pPr lvl="1"/>
             <a:r>
-              <a:rPr lang="en-US" smtClean="0"/>
+              <a:rPr lang="en-US"/>
               <a:t>Second level</a:t>
             </a:r>
           </a:p>
           <a:p>
             <a:pPr lvl="2"/>
             <a:r>
-              <a:rPr lang="en-US" smtClean="0"/>
+              <a:rPr lang="en-US"/>
               <a:t>Third level</a:t>
             </a:r>
           </a:p>
           <a:p>
             <a:pPr lvl="3"/>
             <a:r>
-              <a:rPr lang="en-US" smtClean="0"/>
+              <a:rPr lang="en-US"/>
               <a:t>Fourth level</a:t>
             </a:r>
           </a:p>
           <a:p>
             <a:pPr lvl="4"/>
             <a:r>
-              <a:rPr lang="en-US" smtClean="0"/>
+              <a:rPr lang="en-US"/>
               <a:t>Fifth level</a:t>
             </a:r>
-            <a:endParaRPr lang="en-US"/>
           </a:p>
         </p:txBody>
       </p:sp>
@@ -1294,38 +1328,37 @@
           <a:p>
             <a:pPr lvl="0"/>
             <a:r>
-              <a:rPr lang="en-US" smtClean="0"/>
+              <a:rPr lang="en-US"/>
               <a:t>Click to edit Master text styles</a:t>
             </a:r>
           </a:p>
           <a:p>
             <a:pPr lvl="1"/>
             <a:r>
-              <a:rPr lang="en-US" smtClean="0"/>
+              <a:rPr lang="en-US"/>
               <a:t>Second level</a:t>
             </a:r>
           </a:p>
           <a:p>
             <a:pPr lvl="2"/>
             <a:r>
-              <a:rPr lang="en-US" smtClean="0"/>
+              <a:rPr lang="en-US"/>
               <a:t>Third level</a:t>
             </a:r>
           </a:p>
           <a:p>
             <a:pPr lvl="3"/>
             <a:r>
-              <a:rPr lang="en-US" smtClean="0"/>
+              <a:rPr lang="en-US"/>
               <a:t>Fourth level</a:t>
             </a:r>
           </a:p>
           <a:p>
             <a:pPr lvl="4"/>
             <a:r>
-              <a:rPr lang="en-US" smtClean="0"/>
+              <a:rPr lang="en-US"/>
               <a:t>Fifth level</a:t>
             </a:r>
-            <a:endParaRPr lang="en-US"/>
           </a:p>
         </p:txBody>
       </p:sp>
@@ -1346,7 +1379,7 @@
           <a:p>
             <a:fld id="{5BCAD085-E8A6-8845-BD4E-CB4CCA059FC4}" type="datetimeFigureOut">
               <a:rPr lang="en-US" smtClean="0"/>
-              <a:t>1/27/13</a:t>
+              <a:t>9/17/2026</a:t>
             </a:fld>
             <a:endParaRPr lang="en-US"/>
           </a:p>
@@ -1444,10 +1477,9 @@
           </a:lstStyle>
           <a:p>
             <a:r>
-              <a:rPr lang="en-US" smtClean="0"/>
+              <a:rPr lang="en-US"/>
               <a:t>Click to edit Master title style</a:t>
             </a:r>
-            <a:endParaRPr lang="en-US"/>
           </a:p>
         </p:txBody>
       </p:sp>
@@ -1510,7 +1542,7 @@
           <a:p>
             <a:pPr lvl="0"/>
             <a:r>
-              <a:rPr lang="en-US" smtClean="0"/>
+              <a:rPr lang="en-US"/>
               <a:t>Click to edit Master text styles</a:t>
             </a:r>
           </a:p>
@@ -1566,38 +1598,37 @@
           <a:p>
             <a:pPr lvl="0"/>
             <a:r>
-              <a:rPr lang="en-US" smtClean="0"/>
+              <a:rPr lang="en-US"/>
               <a:t>Click to edit Master text styles</a:t>
             </a:r>
           </a:p>
           <a:p>
             <a:pPr lvl="1"/>
             <a:r>
-              <a:rPr lang="en-US" smtClean="0"/>
+              <a:rPr lang="en-US"/>
               <a:t>Second level</a:t>
             </a:r>
           </a:p>
           <a:p>
             <a:pPr lvl="2"/>
             <a:r>
-              <a:rPr lang="en-US" smtClean="0"/>
+              <a:rPr lang="en-US"/>
               <a:t>Third level</a:t>
             </a:r>
           </a:p>
           <a:p>
             <a:pPr lvl="3"/>
             <a:r>
-              <a:rPr lang="en-US" smtClean="0"/>
+              <a:rPr lang="en-US"/>
               <a:t>Fourth level</a:t>
             </a:r>
           </a:p>
           <a:p>
             <a:pPr lvl="4"/>
             <a:r>
-              <a:rPr lang="en-US" smtClean="0"/>
+              <a:rPr lang="en-US"/>
               <a:t>Fifth level</a:t>
             </a:r>
-            <a:endParaRPr lang="en-US"/>
           </a:p>
         </p:txBody>
       </p:sp>
@@ -1660,7 +1691,7 @@
           <a:p>
             <a:pPr lvl="0"/>
             <a:r>
-              <a:rPr lang="en-US" smtClean="0"/>
+              <a:rPr lang="en-US"/>
               <a:t>Click to edit Master text styles</a:t>
             </a:r>
           </a:p>
@@ -1716,38 +1747,37 @@
           <a:p>
             <a:pPr lvl="0"/>
             <a:r>
-              <a:rPr lang="en-US" smtClean="0"/>
+              <a:rPr lang="en-US"/>
               <a:t>Click to edit Master text styles</a:t>
             </a:r>
           </a:p>
           <a:p>
             <a:pPr lvl="1"/>
             <a:r>
-              <a:rPr lang="en-US" smtClean="0"/>
+              <a:rPr lang="en-US"/>
               <a:t>Second level</a:t>
             </a:r>
           </a:p>
           <a:p>
             <a:pPr lvl="2"/>
             <a:r>
-              <a:rPr lang="en-US" smtClean="0"/>
+              <a:rPr lang="en-US"/>
               <a:t>Third level</a:t>
             </a:r>
           </a:p>
           <a:p>
             <a:pPr lvl="3"/>
             <a:r>
-              <a:rPr lang="en-US" smtClean="0"/>
+              <a:rPr lang="en-US"/>
               <a:t>Fourth level</a:t>
             </a:r>
           </a:p>
           <a:p>
             <a:pPr lvl="4"/>
             <a:r>
-              <a:rPr lang="en-US" smtClean="0"/>
+              <a:rPr lang="en-US"/>
               <a:t>Fifth level</a:t>
             </a:r>
-            <a:endParaRPr lang="en-US"/>
           </a:p>
         </p:txBody>
       </p:sp>
@@ -1768,7 +1798,7 @@
           <a:p>
             <a:fld id="{5BCAD085-E8A6-8845-BD4E-CB4CCA059FC4}" type="datetimeFigureOut">
               <a:rPr lang="en-US" smtClean="0"/>
-              <a:t>1/27/13</a:t>
+              <a:t>9/17/2026</a:t>
             </a:fld>
             <a:endParaRPr lang="en-US"/>
           </a:p>
@@ -1862,10 +1892,9 @@
           <a:lstStyle/>
           <a:p>
             <a:r>
-              <a:rPr lang="en-US" smtClean="0"/>
+              <a:rPr lang="en-US"/>
               <a:t>Click to edit Master title style</a:t>
             </a:r>
-            <a:endParaRPr lang="en-US"/>
           </a:p>
         </p:txBody>
       </p:sp>
@@ -1886,7 +1915,7 @@
           <a:p>
             <a:fld id="{5BCAD085-E8A6-8845-BD4E-CB4CCA059FC4}" type="datetimeFigureOut">
               <a:rPr lang="en-US" smtClean="0"/>
-              <a:t>1/27/13</a:t>
+              <a:t>9/17/2026</a:t>
             </a:fld>
             <a:endParaRPr lang="en-US"/>
           </a:p>
@@ -1981,7 +2010,7 @@
           <a:p>
             <a:fld id="{5BCAD085-E8A6-8845-BD4E-CB4CCA059FC4}" type="datetimeFigureOut">
               <a:rPr lang="en-US" smtClean="0"/>
-              <a:t>1/27/13</a:t>
+              <a:t>9/17/2026</a:t>
             </a:fld>
             <a:endParaRPr lang="en-US"/>
           </a:p>
@@ -2084,10 +2113,9 @@
           </a:lstStyle>
           <a:p>
             <a:r>
-              <a:rPr lang="en-US" smtClean="0"/>
+              <a:rPr lang="en-US"/>
               <a:t>Click to edit Master title style</a:t>
             </a:r>
-            <a:endParaRPr lang="en-US"/>
           </a:p>
         </p:txBody>
       </p:sp>
@@ -2141,38 +2169,37 @@
           <a:p>
             <a:pPr lvl="0"/>
             <a:r>
-              <a:rPr lang="en-US" smtClean="0"/>
+              <a:rPr lang="en-US"/>
               <a:t>Click to edit Master text styles</a:t>
             </a:r>
           </a:p>
           <a:p>
             <a:pPr lvl="1"/>
             <a:r>
-              <a:rPr lang="en-US" smtClean="0"/>
+              <a:rPr lang="en-US"/>
               <a:t>Second level</a:t>
             </a:r>
           </a:p>
           <a:p>
             <a:pPr lvl="2"/>
             <a:r>
-              <a:rPr lang="en-US" smtClean="0"/>
+              <a:rPr lang="en-US"/>
               <a:t>Third level</a:t>
             </a:r>
           </a:p>
           <a:p>
             <a:pPr lvl="3"/>
             <a:r>
-              <a:rPr lang="en-US" smtClean="0"/>
+              <a:rPr lang="en-US"/>
               <a:t>Fourth level</a:t>
             </a:r>
           </a:p>
           <a:p>
             <a:pPr lvl="4"/>
             <a:r>
-              <a:rPr lang="en-US" smtClean="0"/>
+              <a:rPr lang="en-US"/>
               <a:t>Fifth level</a:t>
             </a:r>
-            <a:endParaRPr lang="en-US"/>
           </a:p>
         </p:txBody>
       </p:sp>
@@ -2235,7 +2262,7 @@
           <a:p>
             <a:pPr lvl="0"/>
             <a:r>
-              <a:rPr lang="en-US" smtClean="0"/>
+              <a:rPr lang="en-US"/>
               <a:t>Click to edit Master text styles</a:t>
             </a:r>
           </a:p>
@@ -2258,7 +2285,7 @@
           <a:p>
             <a:fld id="{5BCAD085-E8A6-8845-BD4E-CB4CCA059FC4}" type="datetimeFigureOut">
               <a:rPr lang="en-US" smtClean="0"/>
-              <a:t>1/27/13</a:t>
+              <a:t>9/17/2026</a:t>
             </a:fld>
             <a:endParaRPr lang="en-US"/>
           </a:p>
@@ -2361,10 +2388,9 @@
           </a:lstStyle>
           <a:p>
             <a:r>
-              <a:rPr lang="en-US" smtClean="0"/>
+              <a:rPr lang="en-US"/>
               <a:t>Click to edit Master title style</a:t>
             </a:r>
-            <a:endParaRPr lang="en-US"/>
           </a:p>
         </p:txBody>
       </p:sp>
@@ -2488,7 +2514,7 @@
           <a:p>
             <a:pPr lvl="0"/>
             <a:r>
-              <a:rPr lang="en-US" smtClean="0"/>
+              <a:rPr lang="en-US"/>
               <a:t>Click to edit Master text styles</a:t>
             </a:r>
           </a:p>
@@ -2511,7 +2537,7 @@
           <a:p>
             <a:fld id="{5BCAD085-E8A6-8845-BD4E-CB4CCA059FC4}" type="datetimeFigureOut">
               <a:rPr lang="en-US" smtClean="0"/>
-              <a:t>1/27/13</a:t>
+              <a:t>9/17/2026</a:t>
             </a:fld>
             <a:endParaRPr lang="en-US"/>
           </a:p>
@@ -2620,10 +2646,9 @@
           <a:lstStyle/>
           <a:p>
             <a:r>
-              <a:rPr lang="en-US" smtClean="0"/>
+              <a:rPr lang="en-US"/>
               <a:t>Click to edit Master title style</a:t>
             </a:r>
-            <a:endParaRPr lang="en-US"/>
           </a:p>
         </p:txBody>
       </p:sp>
@@ -2654,38 +2679,37 @@
           <a:p>
             <a:pPr lvl="0"/>
             <a:r>
-              <a:rPr lang="en-US" smtClean="0"/>
+              <a:rPr lang="en-US"/>
               <a:t>Click to edit Master text styles</a:t>
             </a:r>
           </a:p>
           <a:p>
             <a:pPr lvl="1"/>
             <a:r>
-              <a:rPr lang="en-US" smtClean="0"/>
+              <a:rPr lang="en-US"/>
               <a:t>Second level</a:t>
             </a:r>
           </a:p>
           <a:p>
             <a:pPr lvl="2"/>
             <a:r>
-              <a:rPr lang="en-US" smtClean="0"/>
+              <a:rPr lang="en-US"/>
               <a:t>Third level</a:t>
             </a:r>
           </a:p>
           <a:p>
             <a:pPr lvl="3"/>
             <a:r>
-              <a:rPr lang="en-US" smtClean="0"/>
+              <a:rPr lang="en-US"/>
               <a:t>Fourth level</a:t>
             </a:r>
           </a:p>
           <a:p>
             <a:pPr lvl="4"/>
             <a:r>
-              <a:rPr lang="en-US" smtClean="0"/>
+              <a:rPr lang="en-US"/>
               <a:t>Fifth level</a:t>
             </a:r>
-            <a:endParaRPr lang="en-US"/>
           </a:p>
         </p:txBody>
       </p:sp>
@@ -2724,7 +2748,7 @@
           <a:p>
             <a:fld id="{5BCAD085-E8A6-8845-BD4E-CB4CCA059FC4}" type="datetimeFigureOut">
               <a:rPr lang="en-US" smtClean="0"/>
-              <a:t>1/27/13</a:t>
+              <a:t>9/17/2026</a:t>
             </a:fld>
             <a:endParaRPr lang="en-US"/>
           </a:p>
@@ -3083,7 +3107,7 @@
 </file>
 
 <file path=ppt/slides/slide1.xml><?xml version="1.0" encoding="utf-8"?>
-<p:sld xmlns:a="http://schemas.openxmlformats.org/drawingml/2006/main" xmlns:p="http://schemas.openxmlformats.org/presentationml/2006/main" xmlns:r="http://schemas.openxmlformats.org/officeDocument/2006/relationships">
+<p:sld xmlns:a="http://schemas.openxmlformats.org/drawingml/2006/main" xmlns:r="http://schemas.openxmlformats.org/officeDocument/2006/relationships" xmlns:p="http://schemas.openxmlformats.org/presentationml/2006/main">
   <p:cSld>
     <p:bg>
       <p:bgPr>
@@ -3099,7 +3123,14 @@
         <p:cNvGrpSpPr/>
         <p:nvPr/>
       </p:nvGrpSpPr>
-      <p:grpSpPr/>
+      <p:grpSpPr>
+        <a:xfrm>
+          <a:off x="0" y="0"/>
+          <a:ext cx="0" cy="0"/>
+          <a:chOff x="0" y="0"/>
+          <a:chExt cx="0" cy="0"/>
+        </a:xfrm>
+      </p:grpSpPr>
       <p:pic>
         <p:nvPicPr>
           <p:cNvPr id="2" name="Picture 1" descr="image.png"/>
@@ -3141,7 +3172,7 @@
           <a:noFill/>
         </p:spPr>
         <p:txBody>
-          <a:bodyPr wrap="square" lIns="0" rIns="0" tIns="0" bIns="0" anchor="t">
+          <a:bodyPr wrap="square" lIns="0" tIns="0" rIns="0" bIns="0" anchor="t">
             <a:spAutoFit/>
           </a:bodyPr>
           <a:lstStyle/>
@@ -3152,7 +3183,7 @@
               </a:lnSpc>
             </a:pPr>
             <a:r>
-              <a:rPr b="1" sz="5400" i="0" u="none">
+              <a:rPr sz="5400" b="1" i="0" u="none" dirty="0">
                 <a:solidFill>
                   <a:srgbClr val="333333"/>
                 </a:solidFill>
@@ -3161,7 +3192,7 @@
               <a:t>E-HAZID </a:t>
             </a:r>
             <a:r>
-              <a:rPr b="1" sz="5400" i="0" u="none">
+              <a:rPr sz="5400" b="1" i="0" u="none" dirty="0">
                 <a:solidFill>
                   <a:srgbClr val="DA291C"/>
                 </a:solidFill>
@@ -3189,7 +3220,7 @@
           <a:noFill/>
         </p:spPr>
         <p:txBody>
-          <a:bodyPr wrap="square" lIns="0" rIns="0" tIns="0" bIns="0" anchor="t">
+          <a:bodyPr wrap="square" lIns="0" tIns="0" rIns="0" bIns="0" anchor="t">
             <a:spAutoFit/>
           </a:bodyPr>
           <a:lstStyle/>
@@ -3200,7 +3231,7 @@
               </a:lnSpc>
             </a:pPr>
             <a:r>
-              <a:rPr b="0" sz="1800" i="0" u="none">
+              <a:rPr sz="1800" b="0" i="0" u="none" dirty="0">
                 <a:solidFill>
                   <a:srgbClr val="666666"/>
                 </a:solidFill>
@@ -3220,7 +3251,7 @@
 </file>
 
 <file path=ppt/slides/slide2.xml><?xml version="1.0" encoding="utf-8"?>
-<p:sld xmlns:a="http://schemas.openxmlformats.org/drawingml/2006/main" xmlns:p="http://schemas.openxmlformats.org/presentationml/2006/main" xmlns:r="http://schemas.openxmlformats.org/officeDocument/2006/relationships">
+<p:sld xmlns:a="http://schemas.openxmlformats.org/drawingml/2006/main" xmlns:r="http://schemas.openxmlformats.org/officeDocument/2006/relationships" xmlns:p="http://schemas.openxmlformats.org/presentationml/2006/main">
   <p:cSld>
     <p:bg>
       <p:bgPr>
@@ -3236,7 +3267,14 @@
         <p:cNvGrpSpPr/>
         <p:nvPr/>
       </p:nvGrpSpPr>
-      <p:grpSpPr/>
+      <p:grpSpPr>
+        <a:xfrm>
+          <a:off x="0" y="0"/>
+          <a:ext cx="0" cy="0"/>
+          <a:chOff x="0" y="0"/>
+          <a:chExt cx="0" cy="0"/>
+        </a:xfrm>
+      </p:grpSpPr>
       <p:pic>
         <p:nvPicPr>
           <p:cNvPr id="2" name="Picture 1" descr="image.png"/>
@@ -3374,14 +3412,14 @@
           <a:noFill/>
         </p:spPr>
         <p:txBody>
-          <a:bodyPr wrap="square" lIns="0" rIns="0" tIns="0" bIns="0" anchor="t">
+          <a:bodyPr wrap="square" lIns="0" tIns="0" rIns="0" bIns="0" anchor="t">
             <a:spAutoFit/>
           </a:bodyPr>
           <a:lstStyle/>
           <a:p>
             <a:pPr algn="l"/>
             <a:r>
-              <a:rPr b="1" sz="1050" i="0" u="none">
+              <a:rPr sz="1050" b="1" i="0" u="none">
                 <a:solidFill>
                   <a:srgbClr val="DA291C"/>
                 </a:solidFill>
@@ -3409,14 +3447,14 @@
           <a:noFill/>
         </p:spPr>
         <p:txBody>
-          <a:bodyPr wrap="square" lIns="0" rIns="0" tIns="0" bIns="0" anchor="t">
+          <a:bodyPr wrap="square" lIns="0" tIns="0" rIns="0" bIns="0" anchor="t">
             <a:spAutoFit/>
           </a:bodyPr>
           <a:lstStyle/>
           <a:p>
             <a:pPr algn="l"/>
             <a:r>
-              <a:rPr b="1" sz="2100" i="0" u="none">
+              <a:rPr sz="2100" b="1" i="0" u="none">
                 <a:solidFill>
                   <a:srgbClr val="333333"/>
                 </a:solidFill>
@@ -3444,7 +3482,7 @@
           <a:noFill/>
         </p:spPr>
         <p:txBody>
-          <a:bodyPr wrap="square" lIns="0" rIns="0" tIns="0" bIns="0" anchor="t">
+          <a:bodyPr wrap="square" lIns="0" tIns="0" rIns="0" bIns="0" anchor="t">
             <a:spAutoFit/>
           </a:bodyPr>
           <a:lstStyle/>
@@ -3455,7 +3493,7 @@
               </a:lnSpc>
             </a:pPr>
             <a:r>
-              <a:rPr b="0" sz="1350" i="0" u="none">
+              <a:rPr sz="1350" b="0" i="0" u="none">
                 <a:solidFill>
                   <a:srgbClr val="666666"/>
                 </a:solidFill>
@@ -3507,14 +3545,14 @@
           <a:noFill/>
         </p:spPr>
         <p:txBody>
-          <a:bodyPr wrap="square" lIns="0" rIns="0" tIns="0" bIns="0" anchor="t">
+          <a:bodyPr wrap="square" lIns="0" tIns="0" rIns="0" bIns="0" anchor="t">
             <a:spAutoFit/>
           </a:bodyPr>
           <a:lstStyle/>
           <a:p>
             <a:pPr algn="l"/>
             <a:r>
-              <a:rPr b="1" sz="1050" i="0" u="none">
+              <a:rPr sz="1050" b="1" i="0" u="none">
                 <a:solidFill>
                   <a:srgbClr val="DA291C"/>
                 </a:solidFill>
@@ -3542,14 +3580,14 @@
           <a:noFill/>
         </p:spPr>
         <p:txBody>
-          <a:bodyPr wrap="square" lIns="0" rIns="0" tIns="0" bIns="0" anchor="t">
+          <a:bodyPr wrap="square" lIns="0" tIns="0" rIns="0" bIns="0" anchor="t">
             <a:spAutoFit/>
           </a:bodyPr>
           <a:lstStyle/>
           <a:p>
             <a:pPr algn="l"/>
             <a:r>
-              <a:rPr b="1" sz="2100" i="0" u="none">
+              <a:rPr sz="2100" b="1" i="0" u="none">
                 <a:solidFill>
                   <a:srgbClr val="333333"/>
                 </a:solidFill>
@@ -3577,7 +3615,7 @@
           <a:noFill/>
         </p:spPr>
         <p:txBody>
-          <a:bodyPr wrap="square" lIns="0" rIns="0" tIns="0" bIns="0" anchor="t">
+          <a:bodyPr wrap="square" lIns="0" tIns="0" rIns="0" bIns="0" anchor="t">
             <a:spAutoFit/>
           </a:bodyPr>
           <a:lstStyle/>
@@ -3588,7 +3626,7 @@
               </a:lnSpc>
             </a:pPr>
             <a:r>
-              <a:rPr b="0" sz="1350" i="0" u="none">
+              <a:rPr sz="1350" b="0" i="0" u="none">
                 <a:solidFill>
                   <a:srgbClr val="666666"/>
                 </a:solidFill>
@@ -3640,14 +3678,14 @@
           <a:noFill/>
         </p:spPr>
         <p:txBody>
-          <a:bodyPr wrap="square" lIns="0" rIns="0" tIns="0" bIns="0" anchor="t">
+          <a:bodyPr wrap="square" lIns="0" tIns="0" rIns="0" bIns="0" anchor="t">
             <a:spAutoFit/>
           </a:bodyPr>
           <a:lstStyle/>
           <a:p>
             <a:pPr algn="l"/>
             <a:r>
-              <a:rPr b="1" sz="1050" i="0" u="none">
+              <a:rPr sz="1050" b="1" i="0" u="none">
                 <a:solidFill>
                   <a:srgbClr val="DA291C"/>
                 </a:solidFill>
@@ -3675,14 +3713,14 @@
           <a:noFill/>
         </p:spPr>
         <p:txBody>
-          <a:bodyPr wrap="square" lIns="0" rIns="0" tIns="0" bIns="0" anchor="t">
+          <a:bodyPr wrap="square" lIns="0" tIns="0" rIns="0" bIns="0" anchor="t">
             <a:spAutoFit/>
           </a:bodyPr>
           <a:lstStyle/>
           <a:p>
             <a:pPr algn="l"/>
             <a:r>
-              <a:rPr b="1" sz="2100" i="0" u="none">
+              <a:rPr sz="2100" b="1" i="0" u="none">
                 <a:solidFill>
                   <a:srgbClr val="333333"/>
                 </a:solidFill>
@@ -3710,7 +3748,7 @@
           <a:noFill/>
         </p:spPr>
         <p:txBody>
-          <a:bodyPr wrap="square" lIns="0" rIns="0" tIns="0" bIns="0" anchor="t">
+          <a:bodyPr wrap="square" lIns="0" tIns="0" rIns="0" bIns="0" anchor="t">
             <a:spAutoFit/>
           </a:bodyPr>
           <a:lstStyle/>
@@ -3721,7 +3759,7 @@
               </a:lnSpc>
             </a:pPr>
             <a:r>
-              <a:rPr b="0" sz="1350" i="0" u="none">
+              <a:rPr sz="1350" b="0" i="0" u="none">
                 <a:solidFill>
                   <a:srgbClr val="666666"/>
                 </a:solidFill>
@@ -3821,14 +3859,14 @@
           <a:noFill/>
         </p:spPr>
         <p:txBody>
-          <a:bodyPr wrap="square" lIns="0" rIns="0" tIns="0" bIns="0" anchor="t">
+          <a:bodyPr wrap="square" lIns="0" tIns="0" rIns="0" bIns="0" anchor="t">
             <a:spAutoFit/>
           </a:bodyPr>
           <a:lstStyle/>
           <a:p>
             <a:pPr algn="l"/>
             <a:r>
-              <a:rPr b="1" sz="3600" i="0" u="none">
+              <a:rPr sz="3600" b="1" i="0" u="none" dirty="0">
                 <a:solidFill>
                   <a:srgbClr val="DA291C"/>
                 </a:solidFill>
@@ -3848,7 +3886,7 @@
 </file>
 
 <file path=ppt/slides/slide3.xml><?xml version="1.0" encoding="utf-8"?>
-<p:sld xmlns:a="http://schemas.openxmlformats.org/drawingml/2006/main" xmlns:p="http://schemas.openxmlformats.org/presentationml/2006/main" xmlns:r="http://schemas.openxmlformats.org/officeDocument/2006/relationships">
+<p:sld xmlns:a="http://schemas.openxmlformats.org/drawingml/2006/main" xmlns:r="http://schemas.openxmlformats.org/officeDocument/2006/relationships" xmlns:p="http://schemas.openxmlformats.org/presentationml/2006/main">
   <p:cSld>
     <p:bg>
       <p:bgPr>
@@ -3864,7 +3902,14 @@
         <p:cNvGrpSpPr/>
         <p:nvPr/>
       </p:nvGrpSpPr>
-      <p:grpSpPr/>
+      <p:grpSpPr>
+        <a:xfrm>
+          <a:off x="0" y="0"/>
+          <a:ext cx="0" cy="0"/>
+          <a:chOff x="0" y="0"/>
+          <a:chExt cx="0" cy="0"/>
+        </a:xfrm>
+      </p:grpSpPr>
       <p:pic>
         <p:nvPicPr>
           <p:cNvPr id="2" name="Picture 1" descr="image.png"/>
@@ -3954,7 +3999,7 @@
           <a:noFill/>
         </p:spPr>
         <p:txBody>
-          <a:bodyPr wrap="square" lIns="0" rIns="0" tIns="0" bIns="0" anchor="t">
+          <a:bodyPr wrap="square" lIns="0" tIns="0" rIns="0" bIns="0" anchor="t">
             <a:spAutoFit/>
           </a:bodyPr>
           <a:lstStyle/>
@@ -3965,7 +4010,7 @@
               </a:lnSpc>
             </a:pPr>
             <a:r>
-              <a:rPr b="1" sz="1650" i="0" u="none">
+              <a:rPr sz="1650" b="1" i="0" u="none">
                 <a:solidFill>
                   <a:srgbClr val="333333"/>
                 </a:solidFill>
@@ -3974,7 +4019,7 @@
               <a:t>Adversarial Approach:</a:t>
             </a:r>
             <a:r>
-              <a:rPr b="0" sz="1650" i="0" u="none">
+              <a:rPr sz="1650" b="0" i="0" u="none">
                 <a:solidFill>
                   <a:srgbClr val="666666"/>
                 </a:solidFill>
@@ -4002,7 +4047,7 @@
           <a:noFill/>
         </p:spPr>
         <p:txBody>
-          <a:bodyPr wrap="square" lIns="0" rIns="0" tIns="0" bIns="0" anchor="t">
+          <a:bodyPr wrap="square" lIns="0" tIns="0" rIns="0" bIns="0" anchor="t">
             <a:spAutoFit/>
           </a:bodyPr>
           <a:lstStyle/>
@@ -4013,7 +4058,7 @@
               </a:lnSpc>
             </a:pPr>
             <a:r>
-              <a:rPr b="1" sz="1650" i="0" u="none">
+              <a:rPr sz="1650" b="1" i="0" u="none">
                 <a:solidFill>
                   <a:srgbClr val="333333"/>
                 </a:solidFill>
@@ -4022,7 +4067,7 @@
               <a:t>Verified Rigor:</a:t>
             </a:r>
             <a:r>
-              <a:rPr b="0" sz="1650" i="0" u="none">
+              <a:rPr sz="1650" b="0" i="0" u="none">
                 <a:solidFill>
                   <a:srgbClr val="666666"/>
                 </a:solidFill>
@@ -4050,7 +4095,7 @@
           <a:noFill/>
         </p:spPr>
         <p:txBody>
-          <a:bodyPr wrap="square" lIns="0" rIns="0" tIns="0" bIns="0" anchor="t">
+          <a:bodyPr wrap="square" lIns="0" tIns="0" rIns="0" bIns="0" anchor="t">
             <a:spAutoFit/>
           </a:bodyPr>
           <a:lstStyle/>
@@ -4061,7 +4106,7 @@
               </a:lnSpc>
             </a:pPr>
             <a:r>
-              <a:rPr b="1" sz="1650" i="0" u="none">
+              <a:rPr sz="1650" b="1" i="0" u="none">
                 <a:solidFill>
                   <a:srgbClr val="333333"/>
                 </a:solidFill>
@@ -4070,7 +4115,7 @@
               <a:t>Evidence Classification:</a:t>
             </a:r>
             <a:r>
-              <a:rPr b="0" sz="1650" i="0" u="none">
+              <a:rPr sz="1650" b="0" i="0" u="none">
                 <a:solidFill>
                   <a:srgbClr val="666666"/>
                 </a:solidFill>
@@ -4098,7 +4143,7 @@
           <a:noFill/>
         </p:spPr>
         <p:txBody>
-          <a:bodyPr wrap="square" lIns="0" rIns="0" tIns="0" bIns="0" anchor="t">
+          <a:bodyPr wrap="square" lIns="0" tIns="0" rIns="0" bIns="0" anchor="t">
             <a:spAutoFit/>
           </a:bodyPr>
           <a:lstStyle/>
@@ -4109,7 +4154,7 @@
               </a:lnSpc>
             </a:pPr>
             <a:r>
-              <a:rPr b="1" sz="1650" i="0" u="none">
+              <a:rPr sz="1650" b="1" i="0" u="none">
                 <a:solidFill>
                   <a:srgbClr val="333333"/>
                 </a:solidFill>
@@ -4118,7 +4163,7 @@
               <a:t>Massive Efficiency Gain:</a:t>
             </a:r>
             <a:r>
-              <a:rPr b="0" sz="1650" i="0" u="none">
+              <a:rPr sz="1650" b="0" i="0" u="none">
                 <a:solidFill>
                   <a:srgbClr val="666666"/>
                 </a:solidFill>
@@ -4146,14 +4191,14 @@
           <a:noFill/>
         </p:spPr>
         <p:txBody>
-          <a:bodyPr wrap="square" lIns="0" rIns="0" tIns="0" bIns="0" anchor="t">
+          <a:bodyPr wrap="square" lIns="0" tIns="0" rIns="0" bIns="0" anchor="t">
             <a:spAutoFit/>
           </a:bodyPr>
           <a:lstStyle/>
           <a:p>
             <a:pPr algn="l"/>
             <a:r>
-              <a:rPr b="1" sz="3600" i="0" u="none">
+              <a:rPr sz="3600" b="1" i="0" u="none">
                 <a:solidFill>
                   <a:srgbClr val="DA291C"/>
                 </a:solidFill>
@@ -4269,7 +4314,7 @@
 </file>
 
 <file path=ppt/slides/slide4.xml><?xml version="1.0" encoding="utf-8"?>
-<p:sld xmlns:a="http://schemas.openxmlformats.org/drawingml/2006/main" xmlns:p="http://schemas.openxmlformats.org/presentationml/2006/main" xmlns:r="http://schemas.openxmlformats.org/officeDocument/2006/relationships">
+<p:sld xmlns:a="http://schemas.openxmlformats.org/drawingml/2006/main" xmlns:r="http://schemas.openxmlformats.org/officeDocument/2006/relationships" xmlns:p="http://schemas.openxmlformats.org/presentationml/2006/main">
   <p:cSld>
     <p:bg>
       <p:bgPr>
@@ -4285,7 +4330,14 @@
         <p:cNvGrpSpPr/>
         <p:nvPr/>
       </p:nvGrpSpPr>
-      <p:grpSpPr/>
+      <p:grpSpPr>
+        <a:xfrm>
+          <a:off x="0" y="0"/>
+          <a:ext cx="0" cy="0"/>
+          <a:chOff x="0" y="0"/>
+          <a:chExt cx="0" cy="0"/>
+        </a:xfrm>
+      </p:grpSpPr>
       <p:pic>
         <p:nvPicPr>
           <p:cNvPr id="2" name="Picture 1" descr="image.png"/>
@@ -4375,7 +4427,7 @@
           <a:noFill/>
         </p:spPr>
         <p:txBody>
-          <a:bodyPr wrap="square" lIns="0" rIns="0" tIns="0" bIns="0" anchor="t">
+          <a:bodyPr wrap="square" lIns="0" tIns="0" rIns="0" bIns="0" anchor="t">
             <a:spAutoFit/>
           </a:bodyPr>
           <a:lstStyle/>
@@ -4386,7 +4438,7 @@
               </a:lnSpc>
             </a:pPr>
             <a:r>
-              <a:rPr b="1" sz="1650" i="0" u="none">
+              <a:rPr sz="1650" b="1" i="0" u="none">
                 <a:solidFill>
                   <a:srgbClr val="333333"/>
                 </a:solidFill>
@@ -4395,7 +4447,7 @@
               <a:t>Targeted Expert Focus:</a:t>
             </a:r>
             <a:r>
-              <a:rPr b="0" sz="1650" i="0" u="none">
+              <a:rPr sz="1650" b="0" i="0" u="none">
                 <a:solidFill>
                   <a:srgbClr val="666666"/>
                 </a:solidFill>
@@ -4423,7 +4475,7 @@
           <a:noFill/>
         </p:spPr>
         <p:txBody>
-          <a:bodyPr wrap="square" lIns="0" rIns="0" tIns="0" bIns="0" anchor="t">
+          <a:bodyPr wrap="square" lIns="0" tIns="0" rIns="0" bIns="0" anchor="t">
             <a:spAutoFit/>
           </a:bodyPr>
           <a:lstStyle/>
@@ -4434,7 +4486,7 @@
               </a:lnSpc>
             </a:pPr>
             <a:r>
-              <a:rPr b="1" sz="1650" i="0" u="none">
+              <a:rPr sz="1650" b="1" i="0" u="none">
                 <a:solidFill>
                   <a:srgbClr val="333333"/>
                 </a:solidFill>
@@ -4443,7 +4495,7 @@
               <a:t>Tacit Knowledge Capture:</a:t>
             </a:r>
             <a:r>
-              <a:rPr b="0" sz="1650" i="0" u="none">
+              <a:rPr sz="1650" b="0" i="0" u="none">
                 <a:solidFill>
                   <a:srgbClr val="666666"/>
                 </a:solidFill>
@@ -4471,7 +4523,7 @@
           <a:noFill/>
         </p:spPr>
         <p:txBody>
-          <a:bodyPr wrap="square" lIns="0" rIns="0" tIns="0" bIns="0" anchor="t">
+          <a:bodyPr wrap="square" lIns="0" tIns="0" rIns="0" bIns="0" anchor="t">
             <a:spAutoFit/>
           </a:bodyPr>
           <a:lstStyle/>
@@ -4482,7 +4534,7 @@
               </a:lnSpc>
             </a:pPr>
             <a:r>
-              <a:rPr b="1" sz="1650" i="0" u="none">
+              <a:rPr sz="1650" b="1" i="0" u="none">
                 <a:solidFill>
                   <a:srgbClr val="333333"/>
                 </a:solidFill>
@@ -4491,7 +4543,7 @@
               <a:t>Accountable Decision Forks:</a:t>
             </a:r>
             <a:r>
-              <a:rPr b="0" sz="1650" i="0" u="none">
+              <a:rPr sz="1650" b="0" i="0" u="none">
                 <a:solidFill>
                   <a:srgbClr val="666666"/>
                 </a:solidFill>
@@ -4519,7 +4571,7 @@
           <a:noFill/>
         </p:spPr>
         <p:txBody>
-          <a:bodyPr wrap="square" lIns="0" rIns="0" tIns="0" bIns="0" anchor="t">
+          <a:bodyPr wrap="square" lIns="0" tIns="0" rIns="0" bIns="0" anchor="t">
             <a:spAutoFit/>
           </a:bodyPr>
           <a:lstStyle/>
@@ -4530,7 +4582,7 @@
               </a:lnSpc>
             </a:pPr>
             <a:r>
-              <a:rPr b="1" sz="1650" i="0" u="none">
+              <a:rPr sz="1650" b="1" i="0" u="none">
                 <a:solidFill>
                   <a:srgbClr val="333333"/>
                 </a:solidFill>
@@ -4539,7 +4591,7 @@
               <a:t>Continuous Improvement:</a:t>
             </a:r>
             <a:r>
-              <a:rPr b="0" sz="1650" i="0" u="none">
+              <a:rPr sz="1650" b="0" i="0" u="none">
                 <a:solidFill>
                   <a:srgbClr val="666666"/>
                 </a:solidFill>
@@ -4567,14 +4619,14 @@
           <a:noFill/>
         </p:spPr>
         <p:txBody>
-          <a:bodyPr wrap="square" lIns="0" rIns="0" tIns="0" bIns="0" anchor="t">
+          <a:bodyPr wrap="square" lIns="0" tIns="0" rIns="0" bIns="0" anchor="t">
             <a:spAutoFit/>
           </a:bodyPr>
           <a:lstStyle/>
           <a:p>
             <a:pPr algn="l"/>
             <a:r>
-              <a:rPr b="1" sz="3600" i="0" u="none">
+              <a:rPr sz="3600" b="1" i="0" u="none">
                 <a:solidFill>
                   <a:srgbClr val="DA291C"/>
                 </a:solidFill>
@@ -4690,7 +4742,7 @@
 </file>
 
 <file path=ppt/slides/slide5.xml><?xml version="1.0" encoding="utf-8"?>
-<p:sld xmlns:a="http://schemas.openxmlformats.org/drawingml/2006/main" xmlns:p="http://schemas.openxmlformats.org/presentationml/2006/main" xmlns:r="http://schemas.openxmlformats.org/officeDocument/2006/relationships">
+<p:sld xmlns:a="http://schemas.openxmlformats.org/drawingml/2006/main" xmlns:r="http://schemas.openxmlformats.org/officeDocument/2006/relationships" xmlns:p="http://schemas.openxmlformats.org/presentationml/2006/main">
   <p:cSld>
     <p:bg>
       <p:bgPr>
@@ -4706,31 +4758,14 @@
         <p:cNvGrpSpPr/>
         <p:nvPr/>
       </p:nvGrpSpPr>
-      <p:grpSpPr/>
-      <p:pic>
-        <p:nvPicPr>
-          <p:cNvPr id="2" name="Picture 1" descr="image.png"/>
-          <p:cNvPicPr>
-            <a:picLocks noChangeAspect="1"/>
-          </p:cNvPicPr>
-          <p:nvPr/>
-        </p:nvPicPr>
-        <p:blipFill>
-          <a:blip r:embed="rId2"/>
-          <a:stretch>
-            <a:fillRect/>
-          </a:stretch>
-        </p:blipFill>
-        <p:spPr>
-          <a:xfrm>
-            <a:off x="0" y="0"/>
-            <a:ext cx="12192000" cy="6858000"/>
-          </a:xfrm>
-          <a:prstGeom prst="rect">
-            <a:avLst/>
-          </a:prstGeom>
-        </p:spPr>
-      </p:pic>
+      <p:grpSpPr>
+        <a:xfrm>
+          <a:off x="0" y="0"/>
+          <a:ext cx="0" cy="0"/>
+          <a:chOff x="0" y="0"/>
+          <a:chExt cx="0" cy="0"/>
+        </a:xfrm>
+      </p:grpSpPr>
       <p:sp>
         <p:nvSpPr>
           <p:cNvPr id="3" name="TextBox 2"/>
@@ -4748,7 +4783,7 @@
           <a:noFill/>
         </p:spPr>
         <p:txBody>
-          <a:bodyPr wrap="square" lIns="0" rIns="0" tIns="0" bIns="0" anchor="t">
+          <a:bodyPr wrap="square" lIns="0" tIns="0" rIns="0" bIns="0" anchor="t">
             <a:spAutoFit/>
           </a:bodyPr>
           <a:lstStyle/>
@@ -4760,7 +4795,7 @@
               <a:defRPr/>
             </a:pPr>
             <a:r>
-              <a:rPr b="1" sz="4500" i="0" u="none">
+              <a:rPr sz="4500" b="1" i="0" u="none">
                 <a:solidFill>
                   <a:srgbClr val="FBCE07"/>
                 </a:solidFill>
@@ -4788,7 +4823,7 @@
           <a:noFill/>
         </p:spPr>
         <p:txBody>
-          <a:bodyPr wrap="square" lIns="0" rIns="0" tIns="0" bIns="0" anchor="t">
+          <a:bodyPr wrap="square" lIns="0" tIns="0" rIns="0" bIns="0" anchor="t">
             <a:spAutoFit/>
           </a:bodyPr>
           <a:lstStyle/>
@@ -4800,7 +4835,7 @@
               <a:defRPr/>
             </a:pPr>
             <a:r>
-              <a:rPr b="1" sz="4500" i="0" u="none">
+              <a:rPr sz="4500" b="1" i="0" u="none">
                 <a:solidFill>
                   <a:srgbClr val="FBCE07"/>
                 </a:solidFill>
@@ -4828,7 +4863,7 @@
           <a:noFill/>
         </p:spPr>
         <p:txBody>
-          <a:bodyPr wrap="square" lIns="0" rIns="0" tIns="0" bIns="0" anchor="t">
+          <a:bodyPr wrap="square" lIns="0" tIns="0" rIns="0" bIns="0" anchor="t">
             <a:spAutoFit/>
           </a:bodyPr>
           <a:lstStyle/>
@@ -4840,7 +4875,7 @@
               <a:defRPr/>
             </a:pPr>
             <a:r>
-              <a:rPr b="1" sz="4500" i="0" u="none">
+              <a:rPr sz="4500" b="1" i="0" u="none">
                 <a:solidFill>
                   <a:srgbClr val="FBCE07"/>
                 </a:solidFill>
@@ -4868,7 +4903,7 @@
           <a:noFill/>
         </p:spPr>
         <p:txBody>
-          <a:bodyPr wrap="square" lIns="0" rIns="0" tIns="0" bIns="0" anchor="t">
+          <a:bodyPr wrap="square" lIns="0" tIns="0" rIns="0" bIns="0" anchor="t">
             <a:spAutoFit/>
           </a:bodyPr>
           <a:lstStyle/>
@@ -4880,7 +4915,7 @@
               <a:defRPr/>
             </a:pPr>
             <a:r>
-              <a:rPr b="1" sz="4500" i="0" u="none">
+              <a:rPr sz="4500" b="1" i="0" u="none">
                 <a:solidFill>
                   <a:srgbClr val="FBCE07"/>
                 </a:solidFill>
@@ -4908,14 +4943,14 @@
           <a:noFill/>
         </p:spPr>
         <p:txBody>
-          <a:bodyPr wrap="square" lIns="0" rIns="0" tIns="0" bIns="0" anchor="t">
+          <a:bodyPr wrap="square" lIns="0" tIns="0" rIns="0" bIns="0" anchor="t">
             <a:spAutoFit/>
           </a:bodyPr>
           <a:lstStyle/>
           <a:p>
             <a:pPr algn="l"/>
             <a:r>
-              <a:rPr b="1" sz="1800" i="0" u="none">
+              <a:rPr sz="1800" b="1" i="0" u="none">
                 <a:solidFill>
                   <a:srgbClr val="DA291C"/>
                 </a:solidFill>
@@ -4943,7 +4978,7 @@
           <a:noFill/>
         </p:spPr>
         <p:txBody>
-          <a:bodyPr wrap="square" lIns="0" rIns="0" tIns="0" bIns="0" anchor="t">
+          <a:bodyPr wrap="square" lIns="0" tIns="0" rIns="0" bIns="0" anchor="t">
             <a:spAutoFit/>
           </a:bodyPr>
           <a:lstStyle/>
@@ -4954,7 +4989,7 @@
               </a:lnSpc>
             </a:pPr>
             <a:r>
-              <a:rPr b="0" sz="1350" i="0" u="none">
+              <a:rPr sz="1350" b="0" i="0" u="none">
                 <a:solidFill>
                   <a:srgbClr val="666666"/>
                 </a:solidFill>
@@ -4982,14 +5017,14 @@
           <a:noFill/>
         </p:spPr>
         <p:txBody>
-          <a:bodyPr wrap="square" lIns="0" rIns="0" tIns="0" bIns="0" anchor="t">
+          <a:bodyPr wrap="square" lIns="0" tIns="0" rIns="0" bIns="0" anchor="t">
             <a:spAutoFit/>
           </a:bodyPr>
           <a:lstStyle/>
           <a:p>
             <a:pPr algn="l"/>
             <a:r>
-              <a:rPr b="1" sz="1800" i="0" u="none">
+              <a:rPr sz="1800" b="1" i="0" u="none">
                 <a:solidFill>
                   <a:srgbClr val="DA291C"/>
                 </a:solidFill>
@@ -5017,7 +5052,7 @@
           <a:noFill/>
         </p:spPr>
         <p:txBody>
-          <a:bodyPr wrap="square" lIns="0" rIns="0" tIns="0" bIns="0" anchor="t">
+          <a:bodyPr wrap="square" lIns="0" tIns="0" rIns="0" bIns="0" anchor="t">
             <a:spAutoFit/>
           </a:bodyPr>
           <a:lstStyle/>
@@ -5028,7 +5063,7 @@
               </a:lnSpc>
             </a:pPr>
             <a:r>
-              <a:rPr b="0" sz="1350" i="0" u="none">
+              <a:rPr sz="1350" b="0" i="0" u="none">
                 <a:solidFill>
                   <a:srgbClr val="666666"/>
                 </a:solidFill>
@@ -5056,14 +5091,14 @@
           <a:noFill/>
         </p:spPr>
         <p:txBody>
-          <a:bodyPr wrap="square" lIns="0" rIns="0" tIns="0" bIns="0" anchor="t">
+          <a:bodyPr wrap="square" lIns="0" tIns="0" rIns="0" bIns="0" anchor="t">
             <a:spAutoFit/>
           </a:bodyPr>
           <a:lstStyle/>
           <a:p>
             <a:pPr algn="l"/>
             <a:r>
-              <a:rPr b="1" sz="1800" i="0" u="none">
+              <a:rPr sz="1800" b="1" i="0" u="none">
                 <a:solidFill>
                   <a:srgbClr val="DA291C"/>
                 </a:solidFill>
@@ -5091,7 +5126,7 @@
           <a:noFill/>
         </p:spPr>
         <p:txBody>
-          <a:bodyPr wrap="square" lIns="0" rIns="0" tIns="0" bIns="0" anchor="t">
+          <a:bodyPr wrap="square" lIns="0" tIns="0" rIns="0" bIns="0" anchor="t">
             <a:spAutoFit/>
           </a:bodyPr>
           <a:lstStyle/>
@@ -5102,7 +5137,7 @@
               </a:lnSpc>
             </a:pPr>
             <a:r>
-              <a:rPr b="0" sz="1350" i="0" u="none">
+              <a:rPr sz="1350" b="0" i="0" u="none">
                 <a:solidFill>
                   <a:srgbClr val="666666"/>
                 </a:solidFill>
@@ -5130,14 +5165,14 @@
           <a:noFill/>
         </p:spPr>
         <p:txBody>
-          <a:bodyPr wrap="square" lIns="0" rIns="0" tIns="0" bIns="0" anchor="t">
+          <a:bodyPr wrap="square" lIns="0" tIns="0" rIns="0" bIns="0" anchor="t">
             <a:spAutoFit/>
           </a:bodyPr>
           <a:lstStyle/>
           <a:p>
             <a:pPr algn="l"/>
             <a:r>
-              <a:rPr b="1" sz="1800" i="0" u="none">
+              <a:rPr sz="1800" b="1" i="0" u="none">
                 <a:solidFill>
                   <a:srgbClr val="DA291C"/>
                 </a:solidFill>
@@ -5165,7 +5200,7 @@
           <a:noFill/>
         </p:spPr>
         <p:txBody>
-          <a:bodyPr wrap="square" lIns="0" rIns="0" tIns="0" bIns="0" anchor="t">
+          <a:bodyPr wrap="square" lIns="0" tIns="0" rIns="0" bIns="0" anchor="t">
             <a:spAutoFit/>
           </a:bodyPr>
           <a:lstStyle/>
@@ -5176,7 +5211,7 @@
               </a:lnSpc>
             </a:pPr>
             <a:r>
-              <a:rPr b="0" sz="1350" i="0" u="none">
+              <a:rPr sz="1350" b="0" i="0" u="none">
                 <a:solidFill>
                   <a:srgbClr val="666666"/>
                 </a:solidFill>
@@ -5204,14 +5239,14 @@
           <a:noFill/>
         </p:spPr>
         <p:txBody>
-          <a:bodyPr wrap="square" lIns="0" rIns="0" tIns="0" bIns="0" anchor="t">
+          <a:bodyPr wrap="square" lIns="0" tIns="0" rIns="0" bIns="0" anchor="t">
             <a:spAutoFit/>
           </a:bodyPr>
           <a:lstStyle/>
           <a:p>
             <a:pPr algn="l"/>
             <a:r>
-              <a:rPr b="1" sz="3600" i="0" u="none">
+              <a:rPr sz="3600" b="1" i="0" u="none" dirty="0">
                 <a:solidFill>
                   <a:srgbClr val="DA291C"/>
                 </a:solidFill>
@@ -5548,4 +5583,10 @@
   </a:objectDefaults>
   <a:extraClrSchemeLst/>
 </a:theme>
+</file>
+
+<file path=docMetadata/LabelInfo.xml><?xml version="1.0" encoding="utf-8"?>
+<clbl:labelList xmlns:clbl="http://schemas.microsoft.com/office/2020/mipLabelMetadata">
+  <clbl:label id="{d0cb1e24-a0e2-4a4c-9340-733297c9cd7c}" enabled="1" method="Privileged" siteId="{db1e96a8-a3da-442a-930b-235cac24cd5c}" contentBits="0" removed="0"/>
+</clbl:labelList>
 </file>
</xml_diff>